<commit_message>
Fix branching demo link (was pointing at case demo), soften hallucination wording, embed QR codes in deck
</commit_message>
<xml_diff>
--- a/Digital Learning Unlocked - Slide Deck.pptx
+++ b/Digital Learning Unlocked - Slide Deck.pptx
@@ -15271,6 +15271,65 @@
           </a:p>
         </p:txBody>
       </p:sp>
+      <p:pic>
+        <p:nvPicPr>
+          <p:cNvPr id="438" name="Picture 437" descr="workshop-guide-qr.png"/>
+          <p:cNvPicPr>
+            <a:picLocks noChangeAspect="1"/>
+          </p:cNvPicPr>
+          <p:nvPr/>
+        </p:nvPicPr>
+        <p:blipFill>
+          <a:blip r:embed="rId3"/>
+          <a:stretch>
+            <a:fillRect/>
+          </a:stretch>
+        </p:blipFill>
+        <p:spPr>
+          <a:xfrm>
+            <a:off x="9144000" y="2331720"/>
+            <a:ext cx="1828800" cy="1828800"/>
+          </a:xfrm>
+          <a:prstGeom prst="rect">
+            <a:avLst/>
+          </a:prstGeom>
+        </p:spPr>
+      </p:pic>
+      <p:sp>
+        <p:nvSpPr>
+          <p:cNvPr id="439" name="TextBox 438"/>
+          <p:cNvSpPr txBox="1"/>
+          <p:nvPr/>
+        </p:nvSpPr>
+        <p:spPr>
+          <a:xfrm>
+            <a:off x="8503920" y="4315968"/>
+            <a:ext cx="3108960" cy="320040"/>
+          </a:xfrm>
+          <a:prstGeom prst="rect">
+            <a:avLst/>
+          </a:prstGeom>
+          <a:noFill/>
+        </p:spPr>
+        <p:txBody>
+          <a:bodyPr wrap="square">
+            <a:spAutoFit/>
+          </a:bodyPr>
+          <a:lstStyle/>
+          <a:p>
+            <a:pPr algn="ctr"/>
+            <a:r>
+              <a:rPr sz="1400">
+                <a:solidFill>
+                  <a:srgbClr val="1E4258"/>
+                </a:solidFill>
+                <a:latin typeface="Arial"/>
+              </a:rPr>
+              <a:t>Scan for the Workshop Guide</a:t>
+            </a:r>
+          </a:p>
+        </p:txBody>
+      </p:sp>
     </p:spTree>
   </p:cSld>
   <p:clrMapOvr>
@@ -15542,53 +15601,35 @@
           <a:p>
             <a:pPr/>
             <a:r>
-              <a:t>[QR code → Workshop Guide page]</a:t>
-            </a:r>
-          </a:p>
-        </p:txBody>
-      </p:sp>
-      <p:sp>
-        <p:nvSpPr>
-          <p:cNvPr id="109" name="Rectangle 5"/>
-          <p:cNvSpPr/>
-          <p:nvPr/>
-        </p:nvSpPr>
+              <a:t>Scan for the Workshop Guide page</a:t>
+            </a:r>
+          </a:p>
+        </p:txBody>
+      </p:sp>
+      <p:pic>
+        <p:nvPicPr>
+          <p:cNvPr id="109" name="Picture 108" descr="workshop-guide-qr.png"/>
+          <p:cNvPicPr>
+            <a:picLocks noChangeAspect="1"/>
+          </p:cNvPicPr>
+          <p:nvPr/>
+        </p:nvPicPr>
+        <p:blipFill>
+          <a:blip r:embed="rId2"/>
+          <a:stretch>
+            <a:fillRect/>
+          </a:stretch>
+        </p:blipFill>
         <p:spPr>
           <a:xfrm>
             <a:off x="7772400" y="2560320"/>
-            <a:ext cx="3200400" cy="3200401"/>
-          </a:xfrm>
-          <a:prstGeom prst="rect">
-            <a:avLst/>
-          </a:prstGeom>
-          <a:solidFill>
-            <a:srgbClr val="F0F4F8"/>
-          </a:solidFill>
-          <a:ln w="12700">
-            <a:miter lim="400000"/>
-          </a:ln>
-          <a:effectLst>
-            <a:outerShdw sx="100000" sy="100000" kx="0" ky="0" algn="b" rotWithShape="0" blurRad="38100" dist="23000" dir="5400000">
-              <a:srgbClr val="000000">
-                <a:alpha val="35000"/>
-              </a:srgbClr>
-            </a:outerShdw>
-          </a:effectLst>
-        </p:spPr>
-        <p:txBody>
-          <a:bodyPr lIns="45719" rIns="45719" anchor="ctr"/>
-          <a:lstStyle/>
-          <a:p>
-            <a:pPr algn="ctr">
-              <a:defRPr>
-                <a:solidFill>
-                  <a:srgbClr val="FFFFFF"/>
-                </a:solidFill>
-              </a:defRPr>
-            </a:pPr>
-          </a:p>
-        </p:txBody>
-      </p:sp>
+            <a:ext cx="3200400" cy="3200400"/>
+          </a:xfrm>
+          <a:prstGeom prst="rect">
+            <a:avLst/>
+          </a:prstGeom>
+        </p:spPr>
+      </p:pic>
     </p:spTree>
   </p:cSld>
   <p:clrMapOvr>

</xml_diff>

<commit_message>
Text & Audio fidelity badge: Free -> Free / Low (guides), deck spectrum line -> $0 to $20/mo, notes script -> free or low; cleaned double-space cost lines.
</commit_message>
<xml_diff>
--- a/Digital Learning Unlocked - Slide Deck.pptx
+++ b/Digital Learning Unlocked - Slide Deck.pptx
@@ -5904,7 +5904,7 @@
                   <a:srgbClr val="1A2332"/>
                 </a:solidFill>
               </a:rPr>
-              <a:t>• Text and audio, free</a:t>
+              <a:t>• Text and audio, $0 to $20/mo</a:t>
             </a:r>
           </a:p>
           <a:p>
@@ -6107,7 +6107,7 @@
 </p:sld>
 </file>
 
-<file path=ppt/slides/slide16.xml><?xml version="1.0" encoding="utf-8"?>
+<file path=ppt/slides/slide15.xml><?xml version="1.0" encoding="utf-8"?>
 <p:sld xmlns:a="http://schemas.openxmlformats.org/drawingml/2006/main" xmlns:r="http://schemas.openxmlformats.org/officeDocument/2006/relationships" xmlns:p="http://schemas.openxmlformats.org/presentationml/2006/main" xmlns:m="http://schemas.openxmlformats.org/officeDocument/2006/math" xmlns:a14="http://schemas.microsoft.com/office/drawing/2010/main" showMasterSp="1" showMasterPhAnim="1">
   <p:cSld>
     <p:spTree>
@@ -6379,7 +6379,7 @@
 </p:sld>
 </file>
 
-<file path=ppt/slides/slide17.xml><?xml version="1.0" encoding="utf-8"?>
+<file path=ppt/slides/slide16.xml><?xml version="1.0" encoding="utf-8"?>
 <p:sld xmlns:a="http://schemas.openxmlformats.org/drawingml/2006/main" xmlns:r="http://schemas.openxmlformats.org/officeDocument/2006/relationships" xmlns:p="http://schemas.openxmlformats.org/presentationml/2006/main" xmlns:m="http://schemas.openxmlformats.org/officeDocument/2006/math" xmlns:a14="http://schemas.microsoft.com/office/drawing/2010/main" showMasterSp="1" showMasterPhAnim="1">
   <p:cSld>
     <p:spTree>
@@ -7961,6 +7961,278 @@
 </p:sld>
 </file>
 
+<file path=ppt/slides/slide17.xml><?xml version="1.0" encoding="utf-8"?>
+<p:sld xmlns:a="http://schemas.openxmlformats.org/drawingml/2006/main" xmlns:r="http://schemas.openxmlformats.org/officeDocument/2006/relationships" xmlns:p="http://schemas.openxmlformats.org/presentationml/2006/main" xmlns:m="http://schemas.openxmlformats.org/officeDocument/2006/math" xmlns:a14="http://schemas.microsoft.com/office/drawing/2010/main" showMasterSp="1" showMasterPhAnim="1">
+  <p:cSld>
+    <p:spTree>
+      <p:nvGrpSpPr>
+        <p:cNvPr id="1" name=""/>
+        <p:cNvGrpSpPr/>
+        <p:nvPr/>
+      </p:nvGrpSpPr>
+      <p:grpSpPr>
+        <a:xfrm>
+          <a:off x="0" y="0"/>
+          <a:ext cx="0" cy="0"/>
+          <a:chOff x="0" y="0"/>
+          <a:chExt cx="0" cy="0"/>
+        </a:xfrm>
+      </p:grpSpPr>
+      <p:sp>
+        <p:nvSpPr>
+          <p:cNvPr id="2" name="Rectangle 1"/>
+          <p:cNvSpPr/>
+          <p:nvPr/>
+        </p:nvSpPr>
+        <p:spPr>
+          <a:xfrm>
+            <a:off x="-1" y="0"/>
+            <a:ext cx="12191697" cy="1005839"/>
+          </a:xfrm>
+          <a:prstGeom prst="rect">
+            <a:avLst/>
+          </a:prstGeom>
+          <a:solidFill>
+            <a:srgbClr val="2D5F7C"/>
+          </a:solidFill>
+          <a:ln>
+            <a:noFill/>
+          </a:ln>
+          <a:effectLst/>
+        </p:spPr>
+        <p:style>
+          <a:lnRef idx="1">
+            <a:schemeClr val="accent1"/>
+          </a:lnRef>
+          <a:fillRef idx="3">
+            <a:schemeClr val="accent1"/>
+          </a:fillRef>
+          <a:effectRef idx="2">
+            <a:schemeClr val="accent1"/>
+          </a:effectRef>
+          <a:fontRef idx="minor">
+            <a:schemeClr val="lt1"/>
+          </a:fontRef>
+        </p:style>
+        <p:txBody>
+          <a:bodyPr rtlCol="0" anchor="ctr"/>
+          <a:lstStyle/>
+          <a:p>
+            <a:pPr algn="ctr"/>
+          </a:p>
+        </p:txBody>
+      </p:sp>
+      <p:sp>
+        <p:nvSpPr>
+          <p:cNvPr id="3" name="Rectangle 2"/>
+          <p:cNvSpPr/>
+          <p:nvPr/>
+        </p:nvSpPr>
+        <p:spPr>
+          <a:xfrm>
+            <a:off x="640080" y="1371600"/>
+            <a:ext cx="10972801" cy="3657600"/>
+          </a:xfrm>
+          <a:prstGeom prst="rect">
+            <a:avLst/>
+          </a:prstGeom>
+          <a:solidFill>
+            <a:srgbClr val="F0F4F8"/>
+          </a:solidFill>
+          <a:ln>
+            <a:noFill/>
+          </a:ln>
+          <a:effectLst/>
+        </p:spPr>
+        <p:style>
+          <a:lnRef idx="1">
+            <a:schemeClr val="accent1"/>
+          </a:lnRef>
+          <a:fillRef idx="3">
+            <a:schemeClr val="accent1"/>
+          </a:fillRef>
+          <a:effectRef idx="2">
+            <a:schemeClr val="accent1"/>
+          </a:effectRef>
+          <a:fontRef idx="minor">
+            <a:schemeClr val="lt1"/>
+          </a:fontRef>
+        </p:style>
+        <p:txBody>
+          <a:bodyPr rtlCol="0" anchor="ctr"/>
+          <a:lstStyle/>
+          <a:p>
+            <a:pPr algn="ctr"/>
+          </a:p>
+        </p:txBody>
+      </p:sp>
+      <p:sp>
+        <p:nvSpPr>
+          <p:cNvPr id="4" name="Rectangle 3"/>
+          <p:cNvSpPr/>
+          <p:nvPr/>
+        </p:nvSpPr>
+        <p:spPr>
+          <a:xfrm>
+            <a:off x="640080" y="1371600"/>
+            <a:ext cx="50801" cy="3657600"/>
+          </a:xfrm>
+          <a:prstGeom prst="rect">
+            <a:avLst/>
+          </a:prstGeom>
+          <a:solidFill>
+            <a:srgbClr val="2D5F7C"/>
+          </a:solidFill>
+          <a:ln>
+            <a:noFill/>
+          </a:ln>
+          <a:effectLst/>
+        </p:spPr>
+        <p:style>
+          <a:lnRef idx="1">
+            <a:schemeClr val="accent1"/>
+          </a:lnRef>
+          <a:fillRef idx="3">
+            <a:schemeClr val="accent1"/>
+          </a:fillRef>
+          <a:effectRef idx="2">
+            <a:schemeClr val="accent1"/>
+          </a:effectRef>
+          <a:fontRef idx="minor">
+            <a:schemeClr val="lt1"/>
+          </a:fontRef>
+        </p:style>
+        <p:txBody>
+          <a:bodyPr rtlCol="0" anchor="ctr"/>
+          <a:lstStyle/>
+          <a:p>
+            <a:pPr algn="ctr"/>
+          </a:p>
+        </p:txBody>
+      </p:sp>
+      <p:sp>
+        <p:nvSpPr>
+          <p:cNvPr id="5" name="TextBox 4"/>
+          <p:cNvSpPr txBox="1"/>
+          <p:nvPr/>
+        </p:nvSpPr>
+        <p:spPr>
+          <a:xfrm>
+            <a:off x="502919" y="182879"/>
+            <a:ext cx="11155682" cy="444759"/>
+          </a:xfrm>
+          <a:prstGeom prst="rect">
+            <a:avLst/>
+          </a:prstGeom>
+          <a:noFill/>
+        </p:spPr>
+        <p:txBody>
+          <a:bodyPr wrap="square">
+            <a:spAutoFit/>
+          </a:bodyPr>
+          <a:lstStyle/>
+          <a:p>
+            <a:r>
+              <a:rPr sz="2800" b="1">
+                <a:solidFill>
+                  <a:srgbClr val="FFFFFF"/>
+                </a:solidFill>
+              </a:rPr>
+              <a:t>Share-Out (4 min)</a:t>
+            </a:r>
+          </a:p>
+        </p:txBody>
+      </p:sp>
+      <p:sp>
+        <p:nvSpPr>
+          <p:cNvPr id="6" name="TextBox 5"/>
+          <p:cNvSpPr txBox="1"/>
+          <p:nvPr/>
+        </p:nvSpPr>
+        <p:spPr>
+          <a:xfrm>
+            <a:off x="1143000" y="1828800"/>
+            <a:ext cx="9966961" cy="1985576"/>
+          </a:xfrm>
+          <a:prstGeom prst="rect">
+            <a:avLst/>
+          </a:prstGeom>
+          <a:noFill/>
+        </p:spPr>
+        <p:txBody>
+          <a:bodyPr wrap="square">
+            <a:spAutoFit/>
+          </a:bodyPr>
+          <a:lstStyle/>
+          <a:p>
+            <a:r>
+              <a:rPr sz="2200" b="0">
+                <a:solidFill>
+                  <a:srgbClr val="1E4258"/>
+                </a:solidFill>
+              </a:rPr>
+              <a:t>Two or three groups share their plan, 60 seconds each.</a:t>
+            </a:r>
+          </a:p>
+          <a:p>
+            <a:pPr>
+              <a:spcBef>
+                <a:spcPts val="1600"/>
+              </a:spcBef>
+            </a:pPr>
+            <a:r>
+              <a:rPr sz="2200" b="0">
+                <a:solidFill>
+                  <a:srgbClr val="1E4258"/>
+                </a:solidFill>
+              </a:rPr>
+              <a:t>What is your educational need? Your tool? Your first step?</a:t>
+            </a:r>
+          </a:p>
+        </p:txBody>
+      </p:sp>
+      <p:sp>
+        <p:nvSpPr>
+          <p:cNvPr id="7" name="TextBox 6"/>
+          <p:cNvSpPr txBox="1"/>
+          <p:nvPr/>
+        </p:nvSpPr>
+        <p:spPr>
+          <a:xfrm>
+            <a:off x="1143000" y="5303520"/>
+            <a:ext cx="9966961" cy="300594"/>
+          </a:xfrm>
+          <a:prstGeom prst="rect">
+            <a:avLst/>
+          </a:prstGeom>
+          <a:noFill/>
+        </p:spPr>
+        <p:txBody>
+          <a:bodyPr wrap="square">
+            <a:spAutoFit/>
+          </a:bodyPr>
+          <a:lstStyle/>
+          <a:p>
+            <a:r>
+              <a:rPr sz="1600" b="0">
+                <a:solidFill>
+                  <a:srgbClr val="0000FF"/>
+                </a:solidFill>
+              </a:rPr>
+              <a:t>Workshop Guide → Section 7 (the worksheet)</a:t>
+            </a:r>
+          </a:p>
+        </p:txBody>
+      </p:sp>
+    </p:spTree>
+  </p:cSld>
+  <p:clrMapOvr>
+    <a:masterClrMapping/>
+  </p:clrMapOvr>
+  <p:transition xmlns:p14="http://schemas.microsoft.com/office/powerpoint/2010/main" spd="med" advClick="1"/>
+</p:sld>
+</file>
+
 <file path=ppt/slides/slide18.xml><?xml version="1.0" encoding="utf-8"?>
 <p:sld xmlns:a="http://schemas.openxmlformats.org/drawingml/2006/main" xmlns:r="http://schemas.openxmlformats.org/officeDocument/2006/relationships" xmlns:p="http://schemas.openxmlformats.org/presentationml/2006/main" xmlns:m="http://schemas.openxmlformats.org/officeDocument/2006/math" xmlns:a14="http://schemas.microsoft.com/office/drawing/2010/main" showMasterSp="1" showMasterPhAnim="1">
   <p:cSld>
@@ -8138,7 +8410,7 @@
                   <a:srgbClr val="FFFFFF"/>
                 </a:solidFill>
               </a:rPr>
-              <a:t>Share-Out (4 min)</a:t>
+              <a:t>Wrap-Up</a:t>
             </a:r>
           </a:p>
         </p:txBody>
@@ -8171,7 +8443,7 @@
                   <a:srgbClr val="1E4258"/>
                 </a:solidFill>
               </a:rPr>
-              <a:t>Two or three groups share their plan, 60 seconds each.</a:t>
+              <a:t>Start with one tool, one need, one small experiment.</a:t>
             </a:r>
           </a:p>
           <a:p>
@@ -8186,7 +8458,22 @@
                   <a:srgbClr val="1E4258"/>
                 </a:solidFill>
               </a:rPr>
-              <a:t>What is your educational need? Your tool? Your first step?</a:t>
+              <a:t>Everything from today is in the Workshop Guide: bookmark it now.</a:t>
+            </a:r>
+          </a:p>
+          <a:p>
+            <a:pPr>
+              <a:spcBef>
+                <a:spcPts val="1600"/>
+              </a:spcBef>
+            </a:pPr>
+            <a:r>
+              <a:rPr sz="2200" b="0">
+                <a:solidFill>
+                  <a:srgbClr val="1E4258"/>
+                </a:solidFill>
+              </a:rPr>
+              <a:t>The Zero Dollar starter kit is in Section 8.</a:t>
             </a:r>
           </a:p>
         </p:txBody>
@@ -8219,7 +8506,7 @@
                   <a:srgbClr val="0000FF"/>
                 </a:solidFill>
               </a:rPr>
-              <a:t>Workshop Guide → Section 7 (the worksheet)</a:t>
+              <a:t>Workshop Guide → Section 8 (all resources)</a:t>
             </a:r>
           </a:p>
         </p:txBody>
@@ -8236,6 +8523,13 @@
 <file path=ppt/slides/slide19.xml><?xml version="1.0" encoding="utf-8"?>
 <p:sld xmlns:a="http://schemas.openxmlformats.org/drawingml/2006/main" xmlns:r="http://schemas.openxmlformats.org/officeDocument/2006/relationships" xmlns:p="http://schemas.openxmlformats.org/presentationml/2006/main" xmlns:m="http://schemas.openxmlformats.org/officeDocument/2006/math" xmlns:a14="http://schemas.microsoft.com/office/drawing/2010/main" showMasterSp="1" showMasterPhAnim="1">
   <p:cSld>
+    <p:bg>
+      <p:bgPr>
+        <a:solidFill>
+          <a:srgbClr val="1E4258"/>
+        </a:solidFill>
+      </p:bgPr>
+    </p:bg>
     <p:spTree>
       <p:nvGrpSpPr>
         <p:cNvPr id="1" name=""/>
@@ -8252,146 +8546,274 @@
       </p:grpSpPr>
       <p:sp>
         <p:nvSpPr>
-          <p:cNvPr id="2" name="Rectangle 1"/>
+          <p:cNvPr id="433" name="Rectangle 1"/>
           <p:cNvSpPr/>
           <p:nvPr/>
         </p:nvSpPr>
         <p:spPr>
           <a:xfrm>
-            <a:off x="-1" y="0"/>
-            <a:ext cx="12191697" cy="1005839"/>
+            <a:off x="-1" y="5943600"/>
+            <a:ext cx="12191697" cy="914400"/>
           </a:xfrm>
           <a:prstGeom prst="rect">
             <a:avLst/>
           </a:prstGeom>
           <a:solidFill>
-            <a:srgbClr val="2D5F7C"/>
+            <a:srgbClr val="E8833A"/>
           </a:solidFill>
-          <a:ln>
-            <a:noFill/>
+          <a:ln w="12700">
+            <a:miter lim="400000"/>
           </a:ln>
-          <a:effectLst/>
-        </p:spPr>
-        <p:style>
-          <a:lnRef idx="1">
-            <a:schemeClr val="accent1"/>
-          </a:lnRef>
-          <a:fillRef idx="3">
-            <a:schemeClr val="accent1"/>
-          </a:fillRef>
-          <a:effectRef idx="2">
-            <a:schemeClr val="accent1"/>
-          </a:effectRef>
-          <a:fontRef idx="minor">
-            <a:schemeClr val="lt1"/>
-          </a:fontRef>
-        </p:style>
-        <p:txBody>
-          <a:bodyPr rtlCol="0" anchor="ctr"/>
-          <a:lstStyle/>
-          <a:p>
-            <a:pPr algn="ctr"/>
-          </a:p>
-        </p:txBody>
-      </p:sp>
-      <p:sp>
-        <p:nvSpPr>
-          <p:cNvPr id="3" name="Rectangle 2"/>
-          <p:cNvSpPr/>
-          <p:nvPr/>
-        </p:nvSpPr>
-        <p:spPr>
-          <a:xfrm>
-            <a:off x="640080" y="1371600"/>
-            <a:ext cx="10972801" cy="3657600"/>
-          </a:xfrm>
-          <a:prstGeom prst="rect">
-            <a:avLst/>
-          </a:prstGeom>
-          <a:solidFill>
-            <a:srgbClr val="F0F4F8"/>
-          </a:solidFill>
-          <a:ln>
-            <a:noFill/>
+          <a:effectLst>
+            <a:outerShdw sx="100000" sy="100000" kx="0" ky="0" algn="b" rotWithShape="0" blurRad="38100" dist="23000" dir="5400000">
+              <a:srgbClr val="000000">
+                <a:alpha val="35000"/>
+              </a:srgbClr>
+            </a:outerShdw>
+          </a:effectLst>
+        </p:spPr>
+        <p:txBody>
+          <a:bodyPr lIns="45719" rIns="45719" anchor="ctr"/>
+          <a:lstStyle/>
+          <a:p>
+            <a:pPr algn="ctr">
+              <a:defRPr>
+                <a:solidFill>
+                  <a:srgbClr val="FFFFFF"/>
+                </a:solidFill>
+              </a:defRPr>
+            </a:pPr>
+          </a:p>
+        </p:txBody>
+      </p:sp>
+      <p:sp>
+        <p:nvSpPr>
+          <p:cNvPr id="434" name="TextBox 2"/>
+          <p:cNvSpPr txBox="1"/>
+          <p:nvPr/>
+        </p:nvSpPr>
+        <p:spPr>
+          <a:xfrm>
+            <a:off x="960119" y="1828800"/>
+            <a:ext cx="10241282" cy="601623"/>
+          </a:xfrm>
+          <a:prstGeom prst="rect">
+            <a:avLst/>
+          </a:prstGeom>
+          <a:ln w="12700">
+            <a:miter lim="400000"/>
           </a:ln>
-          <a:effectLst/>
-        </p:spPr>
-        <p:style>
-          <a:lnRef idx="1">
-            <a:schemeClr val="accent1"/>
-          </a:lnRef>
-          <a:fillRef idx="3">
-            <a:schemeClr val="accent1"/>
-          </a:fillRef>
-          <a:effectRef idx="2">
-            <a:schemeClr val="accent1"/>
-          </a:effectRef>
-          <a:fontRef idx="minor">
-            <a:schemeClr val="lt1"/>
-          </a:fontRef>
-        </p:style>
-        <p:txBody>
-          <a:bodyPr rtlCol="0" anchor="ctr"/>
-          <a:lstStyle/>
-          <a:p>
-            <a:pPr algn="ctr"/>
-          </a:p>
-        </p:txBody>
-      </p:sp>
-      <p:sp>
-        <p:nvSpPr>
-          <p:cNvPr id="4" name="Rectangle 3"/>
-          <p:cNvSpPr/>
-          <p:nvPr/>
-        </p:nvSpPr>
-        <p:spPr>
-          <a:xfrm>
-            <a:off x="640080" y="1371600"/>
-            <a:ext cx="50801" cy="3657600"/>
-          </a:xfrm>
-          <a:prstGeom prst="rect">
-            <a:avLst/>
-          </a:prstGeom>
-          <a:solidFill>
-            <a:srgbClr val="2D5F7C"/>
-          </a:solidFill>
-          <a:ln>
-            <a:noFill/>
+          <a:extLst>
+            <a:ext uri="{C572A759-6A51-4108-AA02-DFA0A04FC94B}">
+              <ma14:wrappingTextBoxFlag xmlns:ma14="http://schemas.microsoft.com/office/mac/drawingml/2011/main" val="1"/>
+            </a:ext>
+          </a:extLst>
+        </p:spPr>
+        <p:txBody>
+          <a:bodyPr lIns="45719" rIns="45719">
+            <a:spAutoFit/>
+          </a:bodyPr>
+          <a:lstStyle>
+            <a:lvl1pPr algn="ctr">
+              <a:defRPr b="1" sz="4000">
+                <a:solidFill>
+                  <a:srgbClr val="FFFFFF"/>
+                </a:solidFill>
+              </a:defRPr>
+            </a:lvl1pPr>
+          </a:lstStyle>
+          <a:p>
+            <a:pPr/>
+            <a:r>
+              <a:t>Thank You</a:t>
+            </a:r>
+          </a:p>
+        </p:txBody>
+      </p:sp>
+      <p:sp>
+        <p:nvSpPr>
+          <p:cNvPr id="435" name="TextBox 3"/>
+          <p:cNvSpPr txBox="1"/>
+          <p:nvPr/>
+        </p:nvSpPr>
+        <p:spPr>
+          <a:xfrm>
+            <a:off x="960119" y="2926079"/>
+            <a:ext cx="10241282" cy="340183"/>
+          </a:xfrm>
+          <a:prstGeom prst="rect">
+            <a:avLst/>
+          </a:prstGeom>
+          <a:ln w="12700">
+            <a:miter lim="400000"/>
           </a:ln>
-          <a:effectLst/>
-        </p:spPr>
-        <p:style>
-          <a:lnRef idx="1">
-            <a:schemeClr val="accent1"/>
-          </a:lnRef>
-          <a:fillRef idx="3">
-            <a:schemeClr val="accent1"/>
-          </a:fillRef>
-          <a:effectRef idx="2">
-            <a:schemeClr val="accent1"/>
-          </a:effectRef>
-          <a:fontRef idx="minor">
-            <a:schemeClr val="lt1"/>
-          </a:fontRef>
-        </p:style>
-        <p:txBody>
-          <a:bodyPr rtlCol="0" anchor="ctr"/>
-          <a:lstStyle/>
-          <a:p>
-            <a:pPr algn="ctr"/>
-          </a:p>
-        </p:txBody>
-      </p:sp>
-      <p:sp>
-        <p:nvSpPr>
-          <p:cNvPr id="5" name="TextBox 4"/>
+          <a:extLst>
+            <a:ext uri="{C572A759-6A51-4108-AA02-DFA0A04FC94B}">
+              <ma14:wrappingTextBoxFlag xmlns:ma14="http://schemas.microsoft.com/office/mac/drawingml/2011/main" val="1"/>
+            </a:ext>
+          </a:extLst>
+        </p:spPr>
+        <p:txBody>
+          <a:bodyPr lIns="45719" rIns="45719">
+            <a:spAutoFit/>
+          </a:bodyPr>
+          <a:lstStyle>
+            <a:lvl1pPr algn="ctr">
+              <a:defRPr sz="2000">
+                <a:solidFill>
+                  <a:srgbClr val="F4A55A"/>
+                </a:solidFill>
+              </a:defRPr>
+            </a:lvl1pPr>
+          </a:lstStyle>
+          <a:p>
+            <a:pPr/>
+            <a:r>
+              <a:t>Diana Brewer, PA-C</a:t>
+            </a:r>
+          </a:p>
+        </p:txBody>
+      </p:sp>
+      <p:sp>
+        <p:nvSpPr>
+          <p:cNvPr id="436" name="TextBox 4"/>
           <p:cNvSpPr txBox="1"/>
           <p:nvPr/>
         </p:nvSpPr>
         <p:spPr>
           <a:xfrm>
-            <a:off x="502919" y="182879"/>
-            <a:ext cx="11155682" cy="444759"/>
+            <a:off x="960119" y="3474720"/>
+            <a:ext cx="10241282" cy="300594"/>
+          </a:xfrm>
+          <a:prstGeom prst="rect">
+            <a:avLst/>
+          </a:prstGeom>
+          <a:ln w="12700">
+            <a:miter lim="400000"/>
+          </a:ln>
+          <a:extLst>
+            <a:ext uri="{C572A759-6A51-4108-AA02-DFA0A04FC94B}">
+              <ma14:wrappingTextBoxFlag xmlns:ma14="http://schemas.microsoft.com/office/mac/drawingml/2011/main" val="1"/>
+            </a:ext>
+          </a:extLst>
+        </p:spPr>
+        <p:txBody>
+          <a:bodyPr lIns="45719" rIns="45719">
+            <a:spAutoFit/>
+          </a:bodyPr>
+          <a:lstStyle>
+            <a:lvl1pPr algn="ctr">
+              <a:defRPr sz="1600">
+                <a:solidFill>
+                  <a:srgbClr val="FFFFFF"/>
+                </a:solidFill>
+              </a:defRPr>
+            </a:lvl1pPr>
+          </a:lstStyle>
+          <a:p>
+            <a:pPr/>
+            <a:r>
+              <a:t>Knight Cancer Institute Hem/Onc APP Fellowship Director, OHSU  ·  Co-Founder &amp; CMO, Sapient Clinician</a:t>
+            </a:r>
+          </a:p>
+        </p:txBody>
+      </p:sp>
+      <p:sp>
+        <p:nvSpPr>
+          <p:cNvPr id="437" name="TextBox 5"/>
+          <p:cNvSpPr txBox="1"/>
+          <p:nvPr/>
+        </p:nvSpPr>
+        <p:spPr>
+          <a:xfrm>
+            <a:off x="2788920" y="4114800"/>
+            <a:ext cx="6583679" cy="300594"/>
+          </a:xfrm>
+          <a:prstGeom prst="rect">
+            <a:avLst/>
+          </a:prstGeom>
+          <a:ln w="12700">
+            <a:miter lim="400000"/>
+          </a:ln>
+          <a:extLst>
+            <a:ext uri="{C572A759-6A51-4108-AA02-DFA0A04FC94B}">
+              <ma14:wrappingTextBoxFlag xmlns:ma14="http://schemas.microsoft.com/office/mac/drawingml/2011/main" val="1"/>
+            </a:ext>
+          </a:extLst>
+        </p:spPr>
+        <p:txBody>
+          <a:bodyPr lIns="45719" rIns="45719">
+            <a:spAutoFit/>
+          </a:bodyPr>
+          <a:lstStyle>
+            <a:lvl1pPr algn="ctr">
+              <a:defRPr sz="1600" u="sng">
+                <a:solidFill>
+                  <a:srgbClr val="FFFFFF"/>
+                </a:solidFill>
+                <a:uFill>
+                  <a:solidFill>
+                    <a:srgbClr val="0000FF"/>
+                  </a:solidFill>
+                </a:uFill>
+                <a:hlinkClick r:id="rId2" invalidUrl="" action="" tgtFrame="" tooltip="" history="1" highlightClick="0" endSnd="0"/>
+              </a:defRPr>
+            </a:lvl1pPr>
+          </a:lstStyle>
+          <a:p>
+            <a:pPr>
+              <a:defRPr u="none">
+                <a:uFillTx/>
+              </a:defRPr>
+            </a:pPr>
+            <a:r>
+              <a:rPr u="sng">
+                <a:uFill>
+                  <a:solidFill>
+                    <a:srgbClr val="0000FF"/>
+                  </a:solidFill>
+                </a:uFill>
+                <a:hlinkClick r:id="rId2" invalidUrl="" action="" tgtFrame="" tooltip="" history="1" highlightClick="0" endSnd="0"/>
+              </a:rPr>
+              <a:t>brewerd@ohsu.edu</a:t>
+            </a:r>
+          </a:p>
+        </p:txBody>
+      </p:sp>
+      <p:pic>
+        <p:nvPicPr>
+          <p:cNvPr id="438" name="Picture 437" descr="workshop-guide-qr.png"/>
+          <p:cNvPicPr>
+            <a:picLocks noChangeAspect="1"/>
+          </p:cNvPicPr>
+          <p:nvPr/>
+        </p:nvPicPr>
+        <p:blipFill>
+          <a:blip r:embed="rId3"/>
+          <a:stretch>
+            <a:fillRect/>
+          </a:stretch>
+        </p:blipFill>
+        <p:spPr>
+          <a:xfrm>
+            <a:off x="9144000" y="2331720"/>
+            <a:ext cx="1828800" cy="1828800"/>
+          </a:xfrm>
+          <a:prstGeom prst="rect">
+            <a:avLst/>
+          </a:prstGeom>
+        </p:spPr>
+      </p:pic>
+      <p:sp>
+        <p:nvSpPr>
+          <p:cNvPr id="439" name="TextBox 438"/>
+          <p:cNvSpPr txBox="1"/>
+          <p:nvPr/>
+        </p:nvSpPr>
+        <p:spPr>
+          <a:xfrm>
+            <a:off x="8503920" y="4315968"/>
+            <a:ext cx="3108960" cy="320040"/>
           </a:xfrm>
           <a:prstGeom prst="rect">
             <a:avLst/>
@@ -8404,109 +8826,15 @@
           </a:bodyPr>
           <a:lstStyle/>
           <a:p>
-            <a:r>
-              <a:rPr sz="2800" b="1">
-                <a:solidFill>
-                  <a:srgbClr val="FFFFFF"/>
-                </a:solidFill>
+            <a:pPr algn="ctr"/>
+            <a:r>
+              <a:rPr sz="1400">
+                <a:solidFill>
+                  <a:srgbClr val="1E4258"/>
+                </a:solidFill>
+                <a:latin typeface="Arial"/>
               </a:rPr>
-              <a:t>Wrap-Up</a:t>
-            </a:r>
-          </a:p>
-        </p:txBody>
-      </p:sp>
-      <p:sp>
-        <p:nvSpPr>
-          <p:cNvPr id="6" name="TextBox 5"/>
-          <p:cNvSpPr txBox="1"/>
-          <p:nvPr/>
-        </p:nvSpPr>
-        <p:spPr>
-          <a:xfrm>
-            <a:off x="1143000" y="1828800"/>
-            <a:ext cx="9966961" cy="1985576"/>
-          </a:xfrm>
-          <a:prstGeom prst="rect">
-            <a:avLst/>
-          </a:prstGeom>
-          <a:noFill/>
-        </p:spPr>
-        <p:txBody>
-          <a:bodyPr wrap="square">
-            <a:spAutoFit/>
-          </a:bodyPr>
-          <a:lstStyle/>
-          <a:p>
-            <a:r>
-              <a:rPr sz="2200" b="0">
-                <a:solidFill>
-                  <a:srgbClr val="1E4258"/>
-                </a:solidFill>
-              </a:rPr>
-              <a:t>Start with one tool, one need, one small experiment.</a:t>
-            </a:r>
-          </a:p>
-          <a:p>
-            <a:pPr>
-              <a:spcBef>
-                <a:spcPts val="1600"/>
-              </a:spcBef>
-            </a:pPr>
-            <a:r>
-              <a:rPr sz="2200" b="0">
-                <a:solidFill>
-                  <a:srgbClr val="1E4258"/>
-                </a:solidFill>
-              </a:rPr>
-              <a:t>Everything from today is in the Workshop Guide: bookmark it now.</a:t>
-            </a:r>
-          </a:p>
-          <a:p>
-            <a:pPr>
-              <a:spcBef>
-                <a:spcPts val="1600"/>
-              </a:spcBef>
-            </a:pPr>
-            <a:r>
-              <a:rPr sz="2200" b="0">
-                <a:solidFill>
-                  <a:srgbClr val="1E4258"/>
-                </a:solidFill>
-              </a:rPr>
-              <a:t>The Zero Dollar starter kit is in Section 8.</a:t>
-            </a:r>
-          </a:p>
-        </p:txBody>
-      </p:sp>
-      <p:sp>
-        <p:nvSpPr>
-          <p:cNvPr id="7" name="TextBox 6"/>
-          <p:cNvSpPr txBox="1"/>
-          <p:nvPr/>
-        </p:nvSpPr>
-        <p:spPr>
-          <a:xfrm>
-            <a:off x="1143000" y="5303520"/>
-            <a:ext cx="9966961" cy="300594"/>
-          </a:xfrm>
-          <a:prstGeom prst="rect">
-            <a:avLst/>
-          </a:prstGeom>
-          <a:noFill/>
-        </p:spPr>
-        <p:txBody>
-          <a:bodyPr wrap="square">
-            <a:spAutoFit/>
-          </a:bodyPr>
-          <a:lstStyle/>
-          <a:p>
-            <a:r>
-              <a:rPr sz="1600" b="0">
-                <a:solidFill>
-                  <a:srgbClr val="0000FF"/>
-                </a:solidFill>
-              </a:rPr>
-              <a:t>Workshop Guide → Section 8 (all resources)</a:t>
+              <a:t>Scan for the Workshop Guide</a:t>
             </a:r>
           </a:p>
         </p:txBody>
@@ -8735,334 +9063,6 @@
             <a:pPr/>
             <a:r>
               <a:t>You don't need to be a technology expert. You need to be a clinician who knows what your learners need.</a:t>
-            </a:r>
-          </a:p>
-        </p:txBody>
-      </p:sp>
-    </p:spTree>
-  </p:cSld>
-  <p:clrMapOvr>
-    <a:masterClrMapping/>
-  </p:clrMapOvr>
-  <p:transition xmlns:p14="http://schemas.microsoft.com/office/powerpoint/2010/main" spd="med" advClick="1"/>
-</p:sld>
-</file>
-
-<file path=ppt/slides/slide20.xml><?xml version="1.0" encoding="utf-8"?>
-<p:sld xmlns:a="http://schemas.openxmlformats.org/drawingml/2006/main" xmlns:r="http://schemas.openxmlformats.org/officeDocument/2006/relationships" xmlns:p="http://schemas.openxmlformats.org/presentationml/2006/main" xmlns:m="http://schemas.openxmlformats.org/officeDocument/2006/math" xmlns:a14="http://schemas.microsoft.com/office/drawing/2010/main" showMasterSp="1" showMasterPhAnim="1">
-  <p:cSld>
-    <p:bg>
-      <p:bgPr>
-        <a:solidFill>
-          <a:srgbClr val="1E4258"/>
-        </a:solidFill>
-      </p:bgPr>
-    </p:bg>
-    <p:spTree>
-      <p:nvGrpSpPr>
-        <p:cNvPr id="1" name=""/>
-        <p:cNvGrpSpPr/>
-        <p:nvPr/>
-      </p:nvGrpSpPr>
-      <p:grpSpPr>
-        <a:xfrm>
-          <a:off x="0" y="0"/>
-          <a:ext cx="0" cy="0"/>
-          <a:chOff x="0" y="0"/>
-          <a:chExt cx="0" cy="0"/>
-        </a:xfrm>
-      </p:grpSpPr>
-      <p:sp>
-        <p:nvSpPr>
-          <p:cNvPr id="433" name="Rectangle 1"/>
-          <p:cNvSpPr/>
-          <p:nvPr/>
-        </p:nvSpPr>
-        <p:spPr>
-          <a:xfrm>
-            <a:off x="-1" y="5943600"/>
-            <a:ext cx="12191697" cy="914400"/>
-          </a:xfrm>
-          <a:prstGeom prst="rect">
-            <a:avLst/>
-          </a:prstGeom>
-          <a:solidFill>
-            <a:srgbClr val="E8833A"/>
-          </a:solidFill>
-          <a:ln w="12700">
-            <a:miter lim="400000"/>
-          </a:ln>
-          <a:effectLst>
-            <a:outerShdw sx="100000" sy="100000" kx="0" ky="0" algn="b" rotWithShape="0" blurRad="38100" dist="23000" dir="5400000">
-              <a:srgbClr val="000000">
-                <a:alpha val="35000"/>
-              </a:srgbClr>
-            </a:outerShdw>
-          </a:effectLst>
-        </p:spPr>
-        <p:txBody>
-          <a:bodyPr lIns="45719" rIns="45719" anchor="ctr"/>
-          <a:lstStyle/>
-          <a:p>
-            <a:pPr algn="ctr">
-              <a:defRPr>
-                <a:solidFill>
-                  <a:srgbClr val="FFFFFF"/>
-                </a:solidFill>
-              </a:defRPr>
-            </a:pPr>
-          </a:p>
-        </p:txBody>
-      </p:sp>
-      <p:sp>
-        <p:nvSpPr>
-          <p:cNvPr id="434" name="TextBox 2"/>
-          <p:cNvSpPr txBox="1"/>
-          <p:nvPr/>
-        </p:nvSpPr>
-        <p:spPr>
-          <a:xfrm>
-            <a:off x="960119" y="1828800"/>
-            <a:ext cx="10241282" cy="601623"/>
-          </a:xfrm>
-          <a:prstGeom prst="rect">
-            <a:avLst/>
-          </a:prstGeom>
-          <a:ln w="12700">
-            <a:miter lim="400000"/>
-          </a:ln>
-          <a:extLst>
-            <a:ext uri="{C572A759-6A51-4108-AA02-DFA0A04FC94B}">
-              <ma14:wrappingTextBoxFlag xmlns:ma14="http://schemas.microsoft.com/office/mac/drawingml/2011/main" val="1"/>
-            </a:ext>
-          </a:extLst>
-        </p:spPr>
-        <p:txBody>
-          <a:bodyPr lIns="45719" rIns="45719">
-            <a:spAutoFit/>
-          </a:bodyPr>
-          <a:lstStyle>
-            <a:lvl1pPr algn="ctr">
-              <a:defRPr b="1" sz="4000">
-                <a:solidFill>
-                  <a:srgbClr val="FFFFFF"/>
-                </a:solidFill>
-              </a:defRPr>
-            </a:lvl1pPr>
-          </a:lstStyle>
-          <a:p>
-            <a:pPr/>
-            <a:r>
-              <a:t>Thank You</a:t>
-            </a:r>
-          </a:p>
-        </p:txBody>
-      </p:sp>
-      <p:sp>
-        <p:nvSpPr>
-          <p:cNvPr id="435" name="TextBox 3"/>
-          <p:cNvSpPr txBox="1"/>
-          <p:nvPr/>
-        </p:nvSpPr>
-        <p:spPr>
-          <a:xfrm>
-            <a:off x="960119" y="2926079"/>
-            <a:ext cx="10241282" cy="340183"/>
-          </a:xfrm>
-          <a:prstGeom prst="rect">
-            <a:avLst/>
-          </a:prstGeom>
-          <a:ln w="12700">
-            <a:miter lim="400000"/>
-          </a:ln>
-          <a:extLst>
-            <a:ext uri="{C572A759-6A51-4108-AA02-DFA0A04FC94B}">
-              <ma14:wrappingTextBoxFlag xmlns:ma14="http://schemas.microsoft.com/office/mac/drawingml/2011/main" val="1"/>
-            </a:ext>
-          </a:extLst>
-        </p:spPr>
-        <p:txBody>
-          <a:bodyPr lIns="45719" rIns="45719">
-            <a:spAutoFit/>
-          </a:bodyPr>
-          <a:lstStyle>
-            <a:lvl1pPr algn="ctr">
-              <a:defRPr sz="2000">
-                <a:solidFill>
-                  <a:srgbClr val="F4A55A"/>
-                </a:solidFill>
-              </a:defRPr>
-            </a:lvl1pPr>
-          </a:lstStyle>
-          <a:p>
-            <a:pPr/>
-            <a:r>
-              <a:t>Diana Brewer, PA-C</a:t>
-            </a:r>
-          </a:p>
-        </p:txBody>
-      </p:sp>
-      <p:sp>
-        <p:nvSpPr>
-          <p:cNvPr id="436" name="TextBox 4"/>
-          <p:cNvSpPr txBox="1"/>
-          <p:nvPr/>
-        </p:nvSpPr>
-        <p:spPr>
-          <a:xfrm>
-            <a:off x="960119" y="3474720"/>
-            <a:ext cx="10241282" cy="300594"/>
-          </a:xfrm>
-          <a:prstGeom prst="rect">
-            <a:avLst/>
-          </a:prstGeom>
-          <a:ln w="12700">
-            <a:miter lim="400000"/>
-          </a:ln>
-          <a:extLst>
-            <a:ext uri="{C572A759-6A51-4108-AA02-DFA0A04FC94B}">
-              <ma14:wrappingTextBoxFlag xmlns:ma14="http://schemas.microsoft.com/office/mac/drawingml/2011/main" val="1"/>
-            </a:ext>
-          </a:extLst>
-        </p:spPr>
-        <p:txBody>
-          <a:bodyPr lIns="45719" rIns="45719">
-            <a:spAutoFit/>
-          </a:bodyPr>
-          <a:lstStyle>
-            <a:lvl1pPr algn="ctr">
-              <a:defRPr sz="1600">
-                <a:solidFill>
-                  <a:srgbClr val="FFFFFF"/>
-                </a:solidFill>
-              </a:defRPr>
-            </a:lvl1pPr>
-          </a:lstStyle>
-          <a:p>
-            <a:pPr/>
-            <a:r>
-              <a:t>Knight Cancer Institute Hem/Onc APP Fellowship Director, OHSU  ·  Co-Founder &amp; CMO, Sapient Clinician</a:t>
-            </a:r>
-          </a:p>
-        </p:txBody>
-      </p:sp>
-      <p:sp>
-        <p:nvSpPr>
-          <p:cNvPr id="437" name="TextBox 5"/>
-          <p:cNvSpPr txBox="1"/>
-          <p:nvPr/>
-        </p:nvSpPr>
-        <p:spPr>
-          <a:xfrm>
-            <a:off x="2788920" y="4114800"/>
-            <a:ext cx="6583679" cy="300594"/>
-          </a:xfrm>
-          <a:prstGeom prst="rect">
-            <a:avLst/>
-          </a:prstGeom>
-          <a:ln w="12700">
-            <a:miter lim="400000"/>
-          </a:ln>
-          <a:extLst>
-            <a:ext uri="{C572A759-6A51-4108-AA02-DFA0A04FC94B}">
-              <ma14:wrappingTextBoxFlag xmlns:ma14="http://schemas.microsoft.com/office/mac/drawingml/2011/main" val="1"/>
-            </a:ext>
-          </a:extLst>
-        </p:spPr>
-        <p:txBody>
-          <a:bodyPr lIns="45719" rIns="45719">
-            <a:spAutoFit/>
-          </a:bodyPr>
-          <a:lstStyle>
-            <a:lvl1pPr algn="ctr">
-              <a:defRPr sz="1600" u="sng">
-                <a:solidFill>
-                  <a:srgbClr val="FFFFFF"/>
-                </a:solidFill>
-                <a:uFill>
-                  <a:solidFill>
-                    <a:srgbClr val="0000FF"/>
-                  </a:solidFill>
-                </a:uFill>
-                <a:hlinkClick r:id="rId2" invalidUrl="" action="" tgtFrame="" tooltip="" history="1" highlightClick="0" endSnd="0"/>
-              </a:defRPr>
-            </a:lvl1pPr>
-          </a:lstStyle>
-          <a:p>
-            <a:pPr>
-              <a:defRPr u="none">
-                <a:uFillTx/>
-              </a:defRPr>
-            </a:pPr>
-            <a:r>
-              <a:rPr u="sng">
-                <a:uFill>
-                  <a:solidFill>
-                    <a:srgbClr val="0000FF"/>
-                  </a:solidFill>
-                </a:uFill>
-                <a:hlinkClick r:id="rId2" invalidUrl="" action="" tgtFrame="" tooltip="" history="1" highlightClick="0" endSnd="0"/>
-              </a:rPr>
-              <a:t>brewerd@ohsu.edu</a:t>
-            </a:r>
-          </a:p>
-        </p:txBody>
-      </p:sp>
-      <p:pic>
-        <p:nvPicPr>
-          <p:cNvPr id="438" name="Picture 437" descr="workshop-guide-qr.png"/>
-          <p:cNvPicPr>
-            <a:picLocks noChangeAspect="1"/>
-          </p:cNvPicPr>
-          <p:nvPr/>
-        </p:nvPicPr>
-        <p:blipFill>
-          <a:blip r:embed="rId3"/>
-          <a:stretch>
-            <a:fillRect/>
-          </a:stretch>
-        </p:blipFill>
-        <p:spPr>
-          <a:xfrm>
-            <a:off x="9144000" y="2331720"/>
-            <a:ext cx="1828800" cy="1828800"/>
-          </a:xfrm>
-          <a:prstGeom prst="rect">
-            <a:avLst/>
-          </a:prstGeom>
-        </p:spPr>
-      </p:pic>
-      <p:sp>
-        <p:nvSpPr>
-          <p:cNvPr id="439" name="TextBox 438"/>
-          <p:cNvSpPr txBox="1"/>
-          <p:nvPr/>
-        </p:nvSpPr>
-        <p:spPr>
-          <a:xfrm>
-            <a:off x="8503920" y="4315968"/>
-            <a:ext cx="3108960" cy="320040"/>
-          </a:xfrm>
-          <a:prstGeom prst="rect">
-            <a:avLst/>
-          </a:prstGeom>
-          <a:noFill/>
-        </p:spPr>
-        <p:txBody>
-          <a:bodyPr wrap="square">
-            <a:spAutoFit/>
-          </a:bodyPr>
-          <a:lstStyle/>
-          <a:p>
-            <a:pPr algn="ctr"/>
-            <a:r>
-              <a:rPr sz="1400">
-                <a:solidFill>
-                  <a:srgbClr val="1E4258"/>
-                </a:solidFill>
-                <a:latin typeface="Arial"/>
-              </a:rPr>
-              <a:t>Scan for the Workshop Guide</a:t>
             </a:r>
           </a:p>
         </p:txBody>

</xml_diff>

<commit_message>
Slide polish: slide 8 white background (removed inherited navy slide-bg from its duplication lineage), beat-slide footers moved below the cards (5303520 -> 5715000), workflow Upload box lines pinned to 13pt (were falling back to 18pt theme default).
</commit_message>
<xml_diff>
--- a/Digital Learning Unlocked - Slide Deck.pptx
+++ b/Digital Learning Unlocked - Slide Deck.pptx
@@ -2843,6 +2843,7 @@
           <a:p>
             <a:pPr/>
             <a:r>
+              <a:rPr/>
               <a:t>Digital Learning Unlocked</a:t>
             </a:r>
           </a:p>
@@ -2887,6 +2888,7 @@
           <a:p>
             <a:pPr/>
             <a:r>
+              <a:rPr/>
               <a:t>Affordable Tools and Tech for Next-Gen APP Education</a:t>
             </a:r>
           </a:p>
@@ -2931,6 +2933,7 @@
           <a:p>
             <a:pPr/>
             <a:r>
+              <a:rPr/>
               <a:t>Diana Brewer, PA-C  ·  September 2026 APP Fellowship Conference  </a:t>
             </a:r>
           </a:p>
@@ -3043,6 +3046,7 @@
           <a:p>
             <a:pPr/>
             <a:r>
+              <a:rPr/>
               <a:t>The Grounded AI Workflow: No Code Required</a:t>
             </a:r>
           </a:p>
@@ -3278,6 +3282,7 @@
           <a:p>
             <a:pPr/>
             <a:r>
+              <a:rPr/>
               <a:t>Prepare</a:t>
             </a:r>
           </a:p>
@@ -3320,14 +3325,17 @@
               </a:defRPr>
             </a:pPr>
             <a:r>
+              <a:rPr sz="1300"/>
               <a:t>Gather your source material:</a:t>
             </a:r>
             <a:br/>
             <a:r>
+              <a:rPr sz="1300"/>
               <a:t>guidelines, case notes,</a:t>
             </a:r>
             <a:br/>
             <a:r>
+              <a:rPr sz="1300"/>
               <a:t>articles, lecture slides</a:t>
             </a:r>
           </a:p>
@@ -3563,6 +3571,7 @@
           <a:p>
             <a:pPr/>
             <a:r>
+              <a:rPr/>
               <a:t>Upload</a:t>
             </a:r>
           </a:p>
@@ -3605,19 +3614,19 @@
               </a:defRPr>
             </a:pPr>
             <a:r>
-              <a:rPr/>
+              <a:rPr sz="1300"/>
               <a:t>Upload to any assistant</a:t>
             </a:r>
           </a:p>
           <a:p>
             <a:r>
-              <a:rPr/>
+              <a:rPr sz="1300"/>
               <a:t>NotebookLM, a ChatGPT</a:t>
             </a:r>
           </a:p>
           <a:p>
             <a:r>
-              <a:rPr/>
+              <a:rPr sz="1300"/>
               <a:t>Project, or a Claude project</a:t>
             </a:r>
           </a:p>
@@ -3853,6 +3862,7 @@
           <a:p>
             <a:pPr/>
             <a:r>
+              <a:rPr/>
               <a:t>Ground</a:t>
             </a:r>
           </a:p>
@@ -3895,14 +3905,17 @@
               </a:defRPr>
             </a:pPr>
             <a:r>
+              <a:rPr sz="1300"/>
               <a:t>Add this instruction:</a:t>
             </a:r>
             <a:br/>
             <a:r>
+              <a:rPr sz="1300"/>
               <a:t>"Base your response only</a:t>
             </a:r>
             <a:br/>
             <a:r>
+              <a:rPr sz="1300"/>
               <a:t>on the attached documents"</a:t>
             </a:r>
           </a:p>
@@ -4138,6 +4151,7 @@
           <a:p>
             <a:pPr/>
             <a:r>
+              <a:rPr/>
               <a:t>Verify</a:t>
             </a:r>
           </a:p>
@@ -4180,14 +4194,17 @@
               </a:defRPr>
             </a:pPr>
             <a:r>
+              <a:rPr sz="1300"/>
               <a:t>Spot-check lab values,</a:t>
             </a:r>
             <a:br/>
             <a:r>
+              <a:rPr sz="1300"/>
               <a:t>drug dosages, clinical</a:t>
             </a:r>
             <a:br/>
             <a:r>
+              <a:rPr sz="1300"/>
               <a:t>facts against your source</a:t>
             </a:r>
           </a:p>
@@ -4423,6 +4440,7 @@
           <a:p>
             <a:pPr/>
             <a:r>
+              <a:rPr/>
               <a:t>Reuse</a:t>
             </a:r>
           </a:p>
@@ -4465,14 +4483,17 @@
               </a:defRPr>
             </a:pPr>
             <a:r>
+              <a:rPr sz="1300"/>
               <a:t>Save the notebook.</a:t>
             </a:r>
             <a:br/>
             <a:r>
+              <a:rPr sz="1300"/>
               <a:t>It becomes your personal</a:t>
             </a:r>
             <a:br/>
             <a:r>
+              <a:rPr sz="1300"/>
               <a:t>AI case library</a:t>
             </a:r>
           </a:p>
@@ -4990,7 +5011,7 @@
         </p:nvSpPr>
         <p:spPr>
           <a:xfrm>
-            <a:off x="502919" y="5303520"/>
+            <a:off x="502919" y="5715000"/>
             <a:ext cx="11155682" cy="300594"/>
           </a:xfrm>
           <a:prstGeom prst="rect">
@@ -5481,6 +5502,7 @@
           <a:p>
             <a:pPr/>
             <a:r>
+              <a:rPr/>
               <a:t>Objective 3: Simulation Spectrum</a:t>
             </a:r>
           </a:p>
@@ -6073,7 +6095,7 @@
         </p:nvSpPr>
         <p:spPr>
           <a:xfrm>
-            <a:off x="502919" y="5303520"/>
+            <a:off x="502919" y="5715000"/>
             <a:ext cx="11155682" cy="300594"/>
           </a:xfrm>
           <a:prstGeom prst="rect">
@@ -6522,6 +6544,7 @@
           <a:p>
             <a:pPr/>
             <a:r>
+              <a:rPr/>
               <a:t>Turn one of your ideas into a plan you can take back to your program</a:t>
             </a:r>
           </a:p>
@@ -6650,6 +6673,7 @@
           <a:p>
             <a:pPr/>
             <a:r>
+              <a:rPr/>
               <a:t>WHAT THIS IS</a:t>
             </a:r>
           </a:p>
@@ -6694,6 +6718,7 @@
           <a:p>
             <a:pPr/>
             <a:r>
+              <a:rPr/>
               <a:t>You've been discussing tools and ideas after each section, now extend that into a full implementation plan. Pick the idea that feels most feasible.</a:t>
             </a:r>
           </a:p>
@@ -6927,10 +6952,12 @@
               </a:defRPr>
             </a:pPr>
             <a:r>
+              <a:rPr/>
               <a:t>Identify</a:t>
             </a:r>
             <a:br/>
             <a:r>
+              <a:rPr/>
               <a:t>a Need</a:t>
             </a:r>
           </a:p>
@@ -7164,10 +7191,12 @@
               </a:defRPr>
             </a:pPr>
             <a:r>
+              <a:rPr/>
               <a:t>Define</a:t>
             </a:r>
             <a:br/>
             <a:r>
+              <a:rPr/>
               <a:t>Learning Goals</a:t>
             </a:r>
           </a:p>
@@ -7401,10 +7430,12 @@
               </a:defRPr>
             </a:pPr>
             <a:r>
+              <a:rPr/>
               <a:t>Select</a:t>
             </a:r>
             <a:br/>
             <a:r>
+              <a:rPr/>
               <a:t>a Tool</a:t>
             </a:r>
           </a:p>
@@ -7638,10 +7669,12 @@
               </a:defRPr>
             </a:pPr>
             <a:r>
+              <a:rPr/>
               <a:t>Map Pedagogy</a:t>
             </a:r>
             <a:br/>
             <a:r>
+              <a:rPr/>
               <a:t>to Technology</a:t>
             </a:r>
           </a:p>
@@ -7875,10 +7908,12 @@
               </a:defRPr>
             </a:pPr>
             <a:r>
+              <a:rPr/>
               <a:t>Sketch</a:t>
             </a:r>
             <a:br/>
             <a:r>
+              <a:rPr/>
               <a:t>Implementation</a:t>
             </a:r>
           </a:p>
@@ -8625,6 +8660,7 @@
           <a:p>
             <a:pPr/>
             <a:r>
+              <a:rPr/>
               <a:t>Thank You</a:t>
             </a:r>
           </a:p>
@@ -8669,6 +8705,7 @@
           <a:p>
             <a:pPr/>
             <a:r>
+              <a:rPr/>
               <a:t>Diana Brewer, PA-C</a:t>
             </a:r>
           </a:p>
@@ -8713,6 +8750,7 @@
           <a:p>
             <a:pPr/>
             <a:r>
+              <a:rPr/>
               <a:t>Knight Cancer Institute Hem/Onc APP Fellowship Director, OHSU  ·  Co-Founder &amp; CMO, Sapient Clinician</a:t>
             </a:r>
           </a:p>
@@ -9018,6 +9056,7 @@
           <a:p>
             <a:pPr/>
             <a:r>
+              <a:rPr/>
               <a:t>Welcome &amp; Framing</a:t>
             </a:r>
           </a:p>
@@ -9062,6 +9101,7 @@
           <a:p>
             <a:pPr/>
             <a:r>
+              <a:rPr/>
               <a:t>You don't need to be a technology expert. You need to be a clinician who knows what your learners need.</a:t>
             </a:r>
           </a:p>
@@ -9174,6 +9214,7 @@
           <a:p>
             <a:pPr/>
             <a:r>
+              <a:rPr/>
               <a:t>Conflict of Interest &amp; Session Format</a:t>
             </a:r>
           </a:p>
@@ -9219,6 +9260,7 @@
               </a:defRPr>
             </a:pPr>
             <a:r>
+              <a:rPr/>
               <a:t>• COI: Diana Brewer is a co-founder of Sapient Clinician</a:t>
             </a:r>
           </a:p>
@@ -9234,6 +9276,7 @@
               </a:defRPr>
             </a:pPr>
             <a:r>
+              <a:rPr/>
               <a:t>• This session is vendor-neutral</a:t>
             </a:r>
           </a:p>
@@ -9249,6 +9292,7 @@
               </a:defRPr>
             </a:pPr>
             <a:r>
+              <a:rPr/>
               <a:t>• 60 min: ~35 min presentation + 20 min workshop + 5 min share &amp; wrap</a:t>
             </a:r>
           </a:p>
@@ -9264,6 +9308,7 @@
               </a:defRPr>
             </a:pPr>
             <a:r>
+              <a:rPr/>
               <a:t>• Keep the Workshop Guide open on your phone</a:t>
             </a:r>
           </a:p>
@@ -9279,6 +9324,7 @@
               </a:defRPr>
             </a:pPr>
             <a:r>
+              <a:rPr/>
               <a:t>• Think · Pair · Share after each section</a:t>
             </a:r>
           </a:p>
@@ -9294,6 +9340,7 @@
               </a:defRPr>
             </a:pPr>
             <a:r>
+              <a:rPr/>
               <a:t>• Everything stays available after the conference</a:t>
             </a:r>
           </a:p>
@@ -9338,6 +9385,7 @@
           <a:p>
             <a:pPr/>
             <a:r>
+              <a:rPr/>
               <a:t>Scan for the Workshop Guide page</a:t>
             </a:r>
           </a:p>
@@ -9546,6 +9594,7 @@
           <a:p>
             <a:pPr/>
             <a:r>
+              <a:rPr/>
               <a:t>Objective 1: Digital Tools</a:t>
             </a:r>
           </a:p>
@@ -9590,6 +9639,7 @@
           <a:p>
             <a:pPr/>
             <a:r>
+              <a:rPr/>
               <a:t>Free or low-cost platforms for creating interactive content</a:t>
             </a:r>
           </a:p>
@@ -10107,7 +10157,7 @@
         </p:nvSpPr>
         <p:spPr>
           <a:xfrm>
-            <a:off x="502919" y="5303520"/>
+            <a:off x="502919" y="5715000"/>
             <a:ext cx="11155682" cy="300594"/>
           </a:xfrm>
           <a:prstGeom prst="rect">
@@ -10637,7 +10687,7 @@
         </p:nvSpPr>
         <p:spPr>
           <a:xfrm>
-            <a:off x="502919" y="5303520"/>
+            <a:off x="502919" y="5715000"/>
             <a:ext cx="11155682" cy="300594"/>
           </a:xfrm>
           <a:prstGeom prst="rect">
@@ -10960,13 +11010,6 @@
 <file path=ppt/slides/slide8.xml><?xml version="1.0" encoding="utf-8"?>
 <p:sld xmlns:a="http://schemas.openxmlformats.org/drawingml/2006/main" xmlns:r="http://schemas.openxmlformats.org/officeDocument/2006/relationships" xmlns:p="http://schemas.openxmlformats.org/presentationml/2006/main" xmlns:m="http://schemas.openxmlformats.org/officeDocument/2006/math" xmlns:a14="http://schemas.microsoft.com/office/drawing/2010/main" showMasterSp="1" showMasterPhAnim="1">
   <p:cSld>
-    <p:bg>
-      <p:bgPr>
-        <a:solidFill>
-          <a:srgbClr val="2D5F7C"/>
-        </a:solidFill>
-      </p:bgPr>
-    </p:bg>
     <p:spTree>
       <p:nvGrpSpPr>
         <p:cNvPr id="1" name=""/>
@@ -11467,7 +11510,7 @@
         </p:nvSpPr>
         <p:spPr>
           <a:xfrm>
-            <a:off x="502919" y="5303520"/>
+            <a:off x="502919" y="5715000"/>
             <a:ext cx="11155682" cy="300594"/>
           </a:xfrm>
           <a:prstGeom prst="rect">
@@ -12004,7 +12047,7 @@
         </p:nvSpPr>
         <p:spPr>
           <a:xfrm>
-            <a:off x="502919" y="5303520"/>
+            <a:off x="502919" y="5715000"/>
             <a:ext cx="11155682" cy="300594"/>
           </a:xfrm>
           <a:prstGeom prst="rect">

</xml_diff>

<commit_message>
Pre-built notebooks replace DIY demo setup: Section 4 grounding demo now links the PTA case notebook (all six MedEdPORTAL files, link-shared); Beyond the Case gains the AML ziftomenib notebook card (journal club prep via prompts or built-in creators incl. Audio Overview); TPS + slides 11/12 point to the pre-built notebook with ChatGPT/Claude as equal alternatives; notes demo script retargets the PTA notebook (benzocaine question, rubric, audio overview) and inventory lists all three notebooks.
</commit_message>
<xml_diff>
--- a/Digital Learning Unlocked - Slide Deck.pptx
+++ b/Digital Learning Unlocked - Slide Deck.pptx
@@ -4963,12 +4963,12 @@
           <a:lstStyle/>
           <a:p>
             <a:r>
-              <a:rPr sz="1800" b="0">
+              <a:rPr sz="1600">
                 <a:solidFill>
                   <a:srgbClr val="1A2332"/>
                 </a:solidFill>
               </a:rPr>
-              <a:t>Open NotebookLM and try it yourself:</a:t>
+              <a:t>The case notebook is pre-built. Link in the guide, Section 4.</a:t>
             </a:r>
           </a:p>
           <a:p>
@@ -4978,12 +4978,12 @@
               </a:spcBef>
             </a:pPr>
             <a:r>
-              <a:rPr sz="1800" b="0">
+              <a:rPr sz="1600">
                 <a:solidFill>
                   <a:srgbClr val="1A2332"/>
                 </a:solidFill>
               </a:rPr>
-              <a:t>notebooklm.google.com</a:t>
+              <a:t>Ask the benzocaine question and watch it cite the files.</a:t>
             </a:r>
           </a:p>
           <a:p>
@@ -4993,12 +4993,12 @@
               </a:spcBef>
             </a:pPr>
             <a:r>
-              <a:rPr sz="1800" b="0">
+              <a:rPr sz="1600">
                 <a:solidFill>
                   <a:srgbClr val="1A2332"/>
                 </a:solidFill>
               </a:rPr>
-              <a:t>Then run Prompt #1 with the MedEdPORTAL files (guide → Section 4).</a:t>
+              <a:t>No NotebookLM account? ChatGPT or Claude work too.</a:t>
             </a:r>
           </a:p>
         </p:txBody>
@@ -5265,12 +5265,12 @@
               </a:spcBef>
             </a:pPr>
             <a:r>
-              <a:rPr sz="2200" b="0">
+              <a:rPr sz="2200">
                 <a:solidFill>
                   <a:srgbClr val="1E4258"/>
                 </a:solidFill>
               </a:rPr>
-              <a:t>Then the grounded version: the MedEdPORTAL files into NotebookLM, Prompt #1.</a:t>
+              <a:t>Then the grounded version: open the pre-built case notebook (guide, Section 4), or build your own in NotebookLM, ChatGPT, or Claude.</a:t>
             </a:r>
           </a:p>
           <a:p>

</xml_diff>

<commit_message>
Objective 2 signpost slide added (deck 19->20): new slide 9 'Objective 2: Grounded AI Workflow' (circle 4, Guide -> Section 4) clones the Objective 1/3 signpost pattern and slots between The Elephant and Where Ground Truth Lives; notes gain the matching block, all later blocks renumbered 10-20 and retimed +1 min (capstone now 0:30-0:50, buffer 4 min), session-map table rewritten, slide counts 19->20, Blueprint deck model 23->20 and capstone row 0:30-0:50.
</commit_message>
<xml_diff>
--- a/Digital Learning Unlocked - Slide Deck.pptx
+++ b/Digital Learning Unlocked - Slide Deck.pptx
@@ -16,6 +16,7 @@
     <p:sldId id="285" r:id="rId30"/>
     <p:sldId id="262" r:id="rId14"/>
     <p:sldId id="266" r:id="rId18"/>
+    <p:sldId id="300" r:id="rId100"/>
     <p:sldId id="267" r:id="rId19"/>
     <p:sldId id="268" r:id="rId20"/>
     <p:sldId id="269" r:id="rId21"/>
@@ -9103,6 +9104,236 @@
             <a:r>
               <a:rPr/>
               <a:t>You don't need to be a technology expert. You need to be a clinician who knows what your learners need.</a:t>
+            </a:r>
+          </a:p>
+        </p:txBody>
+      </p:sp>
+    </p:spTree>
+  </p:cSld>
+  <p:clrMapOvr>
+    <a:masterClrMapping/>
+  </p:clrMapOvr>
+  <p:transition xmlns:p14="http://schemas.microsoft.com/office/powerpoint/2010/main" spd="med" advClick="1"/>
+</p:sld>
+</file>
+
+<file path=ppt/slides/slide20.xml><?xml version="1.0" encoding="utf-8"?>
+<p:sld xmlns:a="http://schemas.openxmlformats.org/drawingml/2006/main" xmlns:r="http://schemas.openxmlformats.org/officeDocument/2006/relationships" xmlns:p="http://schemas.openxmlformats.org/presentationml/2006/main" xmlns:m="http://schemas.openxmlformats.org/officeDocument/2006/math" xmlns:a14="http://schemas.microsoft.com/office/drawing/2010/main" showMasterSp="1" showMasterPhAnim="1">
+  <p:cSld>
+    <p:bg>
+      <p:bgPr>
+        <a:solidFill>
+          <a:srgbClr val="2D5F7C"/>
+        </a:solidFill>
+      </p:bgPr>
+    </p:bg>
+    <p:spTree>
+      <p:nvGrpSpPr>
+        <p:cNvPr id="1" name=""/>
+        <p:cNvGrpSpPr/>
+        <p:nvPr/>
+      </p:nvGrpSpPr>
+      <p:grpSpPr>
+        <a:xfrm>
+          <a:off x="0" y="0"/>
+          <a:ext cx="0" cy="0"/>
+          <a:chOff x="0" y="0"/>
+          <a:chExt cx="0" cy="0"/>
+        </a:xfrm>
+      </p:grpSpPr>
+      <p:grpSp>
+        <p:nvGrpSpPr>
+          <p:cNvPr id="266" name="Oval 1"/>
+          <p:cNvGrpSpPr/>
+          <p:nvPr/>
+        </p:nvGrpSpPr>
+        <p:grpSpPr>
+          <a:xfrm>
+            <a:off x="914399" y="2285999"/>
+            <a:ext cx="1097282" cy="1097282"/>
+            <a:chOff x="0" y="0"/>
+            <a:chExt cx="1097280" cy="1097280"/>
+          </a:xfrm>
+        </p:grpSpPr>
+        <p:sp>
+          <p:nvSpPr>
+            <p:cNvPr id="264" name="Circle"/>
+            <p:cNvSpPr/>
+            <p:nvPr/>
+          </p:nvSpPr>
+          <p:spPr>
+            <a:xfrm>
+              <a:off x="-1" y="-1"/>
+              <a:ext cx="1097282" cy="1097282"/>
+            </a:xfrm>
+            <a:prstGeom prst="ellipse">
+              <a:avLst/>
+            </a:prstGeom>
+            <a:solidFill>
+              <a:srgbClr val="E8833A"/>
+            </a:solidFill>
+            <a:ln w="12700" cap="flat">
+              <a:noFill/>
+              <a:miter lim="400000"/>
+            </a:ln>
+            <a:effectLst>
+              <a:outerShdw sx="100000" sy="100000" kx="0" ky="0" algn="b" rotWithShape="0" blurRad="38100" dist="23000" dir="5400000">
+                <a:srgbClr val="000000">
+                  <a:alpha val="35000"/>
+                </a:srgbClr>
+              </a:outerShdw>
+            </a:effectLst>
+          </p:spPr>
+          <p:txBody>
+            <a:bodyPr wrap="square" lIns="45719" tIns="45719" rIns="45719" bIns="45719" numCol="1" anchor="ctr">
+              <a:noAutofit/>
+            </a:bodyPr>
+            <a:lstStyle/>
+            <a:p>
+              <a:pPr algn="ctr">
+                <a:defRPr b="1" sz="3600">
+                  <a:solidFill>
+                    <a:srgbClr val="FFFFFF"/>
+                  </a:solidFill>
+                </a:defRPr>
+              </a:pPr>
+            </a:p>
+          </p:txBody>
+        </p:sp>
+        <p:sp>
+          <p:nvSpPr>
+            <p:cNvPr id="265" name="5"/>
+            <p:cNvSpPr txBox="1"/>
+            <p:nvPr/>
+          </p:nvSpPr>
+          <p:spPr>
+            <a:xfrm>
+              <a:off x="206412" y="273972"/>
+              <a:ext cx="684456" cy="549336"/>
+            </a:xfrm>
+            <a:prstGeom prst="rect">
+              <a:avLst/>
+            </a:prstGeom>
+            <a:noFill/>
+            <a:ln w="12700" cap="flat">
+              <a:noFill/>
+              <a:miter lim="400000"/>
+            </a:ln>
+            <a:effectLst/>
+            <a:extLst>
+              <a:ext uri="{C572A759-6A51-4108-AA02-DFA0A04FC94B}">
+                <ma14:wrappingTextBoxFlag xmlns:ma14="http://schemas.microsoft.com/office/mac/drawingml/2011/main" val="1"/>
+              </a:ext>
+            </a:extLst>
+          </p:spPr>
+          <p:txBody>
+            <a:bodyPr wrap="square" lIns="45719" tIns="45719" rIns="45719" bIns="45719" numCol="1" anchor="ctr">
+              <a:spAutoFit/>
+            </a:bodyPr>
+            <a:lstStyle>
+              <a:lvl1pPr algn="ctr">
+                <a:defRPr b="1" sz="3600">
+                  <a:solidFill>
+                    <a:srgbClr val="FFFFFF"/>
+                  </a:solidFill>
+                </a:defRPr>
+              </a:lvl1pPr>
+            </a:lstStyle>
+            <a:p>
+              <a:pPr/>
+              <a:r>
+                <a:t>4</a:t>
+              </a:r>
+            </a:p>
+          </p:txBody>
+        </p:sp>
+      </p:grpSp>
+      <p:sp>
+        <p:nvSpPr>
+          <p:cNvPr id="267" name="TextBox 2"/>
+          <p:cNvSpPr txBox="1"/>
+          <p:nvPr/>
+        </p:nvSpPr>
+        <p:spPr>
+          <a:xfrm>
+            <a:off x="2331719" y="2286000"/>
+            <a:ext cx="8595362" cy="497047"/>
+          </a:xfrm>
+          <a:prstGeom prst="rect">
+            <a:avLst/>
+          </a:prstGeom>
+          <a:ln w="12700">
+            <a:miter lim="400000"/>
+          </a:ln>
+          <a:extLst>
+            <a:ext uri="{C572A759-6A51-4108-AA02-DFA0A04FC94B}">
+              <ma14:wrappingTextBoxFlag xmlns:ma14="http://schemas.microsoft.com/office/mac/drawingml/2011/main" val="1"/>
+            </a:ext>
+          </a:extLst>
+        </p:spPr>
+        <p:txBody>
+          <a:bodyPr lIns="45719" rIns="45719">
+            <a:spAutoFit/>
+          </a:bodyPr>
+          <a:lstStyle>
+            <a:lvl1pPr>
+              <a:defRPr b="1" sz="3200">
+                <a:solidFill>
+                  <a:srgbClr val="FFFFFF"/>
+                </a:solidFill>
+              </a:defRPr>
+            </a:lvl1pPr>
+          </a:lstStyle>
+          <a:p>
+            <a:pPr/>
+            <a:r>
+              <a:rPr/>
+              <a:t>Objective 2: Grounded AI Workflow</a:t>
+            </a:r>
+          </a:p>
+        </p:txBody>
+      </p:sp>
+      <p:sp>
+        <p:nvSpPr>
+          <p:cNvPr id="268" name="TextBox 3"/>
+          <p:cNvSpPr txBox="1"/>
+          <p:nvPr/>
+        </p:nvSpPr>
+        <p:spPr>
+          <a:xfrm>
+            <a:off x="2331719" y="3200400"/>
+            <a:ext cx="8595362" cy="333088"/>
+          </a:xfrm>
+          <a:prstGeom prst="rect">
+            <a:avLst/>
+          </a:prstGeom>
+          <a:ln w="12700">
+            <a:miter lim="400000"/>
+          </a:ln>
+          <a:extLst>
+            <a:ext uri="{C572A759-6A51-4108-AA02-DFA0A04FC94B}">
+              <ma14:wrappingTextBoxFlag xmlns:ma14="http://schemas.microsoft.com/office/mac/drawingml/2011/main" val="1"/>
+            </a:ext>
+          </a:extLst>
+        </p:spPr>
+        <p:txBody>
+          <a:bodyPr lIns="45719" rIns="45719">
+            <a:spAutoFit/>
+          </a:bodyPr>
+          <a:lstStyle>
+            <a:lvl1pPr>
+              <a:defRPr>
+                <a:solidFill>
+                  <a:srgbClr val="F4A55A"/>
+                </a:solidFill>
+              </a:defRPr>
+            </a:lvl1pPr>
+          </a:lstStyle>
+          <a:p>
+            <a:pPr/>
+            <a:r>
+              <a:rPr/>
+              <a:t>Upload published sources, get cited answers, every time · Guide → Section 4</a:t>
             </a:r>
           </a:p>
         </p:txBody>

</xml_diff>